<commit_message>
Fix rogue boxes: strip blurred glows from PDF/PPTX exports (keep on live HTML)
</commit_message>
<xml_diff>
--- a/DISTRIKT-Paid-Media-B.pptx
+++ b/DISTRIKT-Paid-Media-B.pptx
@@ -4993,16 +4993,16 @@
           <a:solidFill>
             <a:srgbClr val="FFFFFF"/>
           </a:solidFill>
-          <a:ln w="25400">
+          <a:ln w="31750">
             <a:solidFill>
               <a:srgbClr val="7B3BE9"/>
             </a:solidFill>
             <a:prstDash val="solid"/>
           </a:ln>
           <a:effectLst>
-            <a:outerShdw sx="100000" sy="100000" kx="0" ky="0" algn="bl" rotWithShape="0" blurRad="355600" dist="50800" dir="16200000">
-              <a:srgbClr val="7B3BE9">
-                <a:alpha val="55000"/>
+            <a:outerShdw sx="100000" sy="100000" kx="0" ky="0" algn="bl" rotWithShape="0" blurRad="114300" dist="38100" dir="5400000">
+              <a:srgbClr val="000000">
+                <a:alpha val="18000"/>
               </a:srgbClr>
             </a:outerShdw>
           </a:effectLst>

</xml_diff>